<commit_message>
Generate Lecture 3 slide deck (HTML/HTML5 Fundamentals); fix code-note overlap
- CSC336-Lecture-03-HTML-and-HTML5-Fundamentals.pptx (27 slides): embeds
  all 13 real screenshots from the lecture, plus native tables (void
  elements, block/inline, global attributes, pre/code tags, entities) and
  code slides (font tag, nested lists)
- Fix deckBuilder's code-slide note box so it never runs into the footer
  when the code box itself is tall (was overlapping by ~0.15in for long
  snippets); regenerated Lecture 2 with the same fix

Co-Authored-By: Claude Sonnet 5 <noreply@anthropic.com>
</commit_message>
<xml_diff>
--- a/slides/CSC336-Lecture-02-Tiered-Web-Architecture.pptx
+++ b/slides/CSC336-Lecture-02-Tiered-Web-Architecture.pptx
@@ -5304,7 +5304,7 @@
         <p:spPr>
           <a:xfrm>
             <a:off x="640080" y="4800600"/>
-            <a:ext cx="10911535" cy="1097280"/>
+            <a:ext cx="10911535" cy="1463040"/>
           </a:xfrm>
           <a:prstGeom prst="rect">
             <a:avLst/>
@@ -10405,7 +10405,7 @@
         <p:spPr>
           <a:xfrm>
             <a:off x="640080" y="4416552"/>
-            <a:ext cx="10911535" cy="1097280"/>
+            <a:ext cx="10911535" cy="1847088"/>
           </a:xfrm>
           <a:prstGeom prst="rect">
             <a:avLst/>

</xml_diff>